<commit_message>
fix: rename model version to v6.0 across all source citations
Per IC convention, a banker-facing deck uses release-style versioning
(v6.0) rather than internal build numbers (v60-53). Swept five
citations across slides 3, 4, 5, 6, 8 from "v60-40" to "v6.0".

Boundless v2.6 debt facility reference untouched — that's a separate
product, not the financial model.

Co-Authored-By: Claude Opus 4.7 (1M context) <noreply@anthropic.com>
</commit_message>
<xml_diff>
--- a/EDGE-EastWest-Bank-TaxEquity-IC-Memo.pptx
+++ b/EDGE-EastWest-Bank-TaxEquity-IC-Memo.pptx
@@ -16454,7 +16454,7 @@
                 </a:solidFill>
                 <a:latin typeface="Calibri"/>
               </a:rPr>
-              <a:t>EDGE Energy IC Memo  ·  Confidential  ·  Source: EDGE financial model v60-40 · §6418 comparative analysis</a:t>
+              <a:t>EDGE Energy IC Memo  ·  Confidential  ·  Source: EDGE financial model v6.0 · §6418 comparative analysis</a:t>
             </a:r>
           </a:p>
         </p:txBody>
@@ -18075,7 +18075,7 @@
                 </a:solidFill>
                 <a:latin typeface="Calibri"/>
               </a:rPr>
-              <a:t>EDGE Energy IC Memo  ·  Confidential  ·  Source: EDGE financial model v60-40 · Boundless v2.6 debt term sheet</a:t>
+              <a:t>EDGE Energy IC Memo  ·  Confidential  ·  Source: EDGE financial model v6.0 · Boundless v2.6 debt term sheet</a:t>
             </a:r>
           </a:p>
         </p:txBody>
@@ -21393,7 +21393,7 @@
                 </a:solidFill>
                 <a:latin typeface="Calibri"/>
               </a:rPr>
-              <a:t>EDGE Energy IC Memo  ·  Confidential  ·  Source: EDGE financial model v60-40 · §704(b) waterfall</a:t>
+              <a:t>EDGE Energy IC Memo  ·  Confidential  ·  Source: EDGE financial model v6.0 · §704(b) waterfall</a:t>
             </a:r>
           </a:p>
         </p:txBody>
@@ -24322,7 +24322,7 @@
                 </a:solidFill>
                 <a:latin typeface="Calibri"/>
               </a:rPr>
-              <a:t>EDGE Energy IC Memo  ·  Confidential  ·  Source: EDGE financial model v60-40 · Class A flip waterfall</a:t>
+              <a:t>EDGE Energy IC Memo  ·  Confidential  ·  Source: EDGE financial model v6.0 · Class A flip waterfall</a:t>
             </a:r>
           </a:p>
         </p:txBody>
@@ -27452,7 +27452,7 @@
                 </a:solidFill>
                 <a:latin typeface="Calibri"/>
               </a:rPr>
-              <a:t>Financial model v60-40 (audit-converged)</a:t>
+              <a:t>Financial model v6.0 (audit-converged)</a:t>
             </a:r>
           </a:p>
         </p:txBody>

</xml_diff>